<commit_message>
Corrige nota da árvore nos slides do vídeo e lista os novos arquivos
O gráfico de modelos mostrava 0,75 para a Árvore de Decisão; o valor do
teste é 0,7448 (0,74), como no README. docs/README.md passa a listar os
slides e o roteiro do vídeo.

Co-Authored-By: Claude Opus 5.5 <noreply@anthropic.com>
</commit_message>
<xml_diff>
--- a/docs/apresentacao_video_grupo12.pptx
+++ b/docs/apresentacao_video_grupo12.pptx
@@ -116,31 +116,31 @@
   <p:extLst>
     <p:ext uri="{521415D9-36F7-43E2-AB2F-B90AF26B5E84}">
       <p14:sectionLst xmlns:p14="http://schemas.microsoft.com/office/powerpoint/2010/main">
-        <p14:section name="Abertura" id="{9873e282-c8eb-abae-ca08-964b6fcd198d}">
+        <p14:section name="Abertura" id="{6e25f3b7-ec90-5dc9-5a92-ee5138f53853}">
           <p14:sldIdLst>
             <p14:sldId id="256"/>
           </p14:sldIdLst>
         </p14:section>
-        <p14:section name="Problema e dados" id="{d8792035-f35d-3da9-891b-3b5751f6b303}">
+        <p14:section name="Problema e dados" id="{765d4d2e-53c7-357a-c163-cf918e62dd7b}">
           <p14:sldIdLst>
             <p14:sldId id="257"/>
             <p14:sldId id="258"/>
           </p14:sldIdLst>
         </p14:section>
-        <p14:section name="Análise e preparação" id="{aa91c76b-d911-9cd2-0c5a-671fc6250272}">
+        <p14:section name="Análise e preparação" id="{06d17a41-9475-926f-ed83-b459e8ae4649}">
           <p14:sldIdLst>
             <p14:sldId id="259"/>
             <p14:sldId id="260"/>
           </p14:sldIdLst>
         </p14:section>
-        <p14:section name="Resultados" id="{1b62db73-ba7d-ea39-ef71-27370708d361}">
+        <p14:section name="Resultados" id="{b9fc9bdc-b9b6-9457-22f2-1e469b49dd99}">
           <p14:sldIdLst>
             <p14:sldId id="261"/>
             <p14:sldId id="262"/>
             <p14:sldId id="263"/>
           </p14:sldIdLst>
         </p14:section>
-        <p14:section name="Limites e recomendação" id="{4bdf3433-c907-14e9-b84b-f7f41960ef75}">
+        <p14:section name="Limites e recomendação" id="{8e917e94-7ac4-6332-503a-d52abb1b93e3}">
           <p14:sldIdLst>
             <p14:sldId id="264"/>
             <p14:sldId id="265"/>
@@ -664,16 +664,16 @@
                   <c:v>0.5</c:v>
                 </c:pt>
                 <c:pt idx="1">
-                  <c:v>0.745</c:v>
+                  <c:v>0.7448</c:v>
                 </c:pt>
                 <c:pt idx="2">
-                  <c:v>0.75</c:v>
+                  <c:v>0.7497</c:v>
                 </c:pt>
                 <c:pt idx="3">
                   <c:v>0.788</c:v>
                 </c:pt>
                 <c:pt idx="4">
-                  <c:v>0.797</c:v>
+                  <c:v>0.7965</c:v>
                 </c:pt>
               </c:numCache>
             </c:numRef>

</xml_diff>